<commit_message>
Simplify Enzo slides to 9th-grade plain language
Shorten explanations, use everyday words and sports comparisons,
and keep the same 11-slide structure with no competition results.

Co-authored-by: SivaBKPalla <SivaBKPalla@users.noreply.github.com>
</commit_message>
<xml_diff>
--- a/enzo-presentation/Enzo_Crescendo_GoogleSlides.pptx
+++ b/enzo-presentation/Enzo_Crescendo_GoogleSlides.pptx
@@ -512,7 +512,7 @@
           <a:lstStyle/>
           <a:p>
             <a:r>
-              <a:t>Open with the brand. No scoreboards — design only.</a:t>
+              <a:t>Say the robot name clearly. This talk is about design, not scores.</a:t>
             </a:r>
           </a:p>
         </p:txBody>
@@ -582,7 +582,7 @@
           <a:lstStyle/>
           <a:p>
             <a:r>
-              <a:t>Thesis slide. Pause between the five reasons.</a:t>
+              <a:t>Slow down and hit each of the five points.</a:t>
             </a:r>
           </a:p>
         </p:txBody>
@@ -652,7 +652,7 @@
           <a:lstStyle/>
           <a:p>
             <a:r>
-              <a:t>Close and invite design questions only.</a:t>
+              <a:t>End here. Invite simple questions about design or the game.</a:t>
             </a:r>
           </a:p>
         </p:txBody>
@@ -722,7 +722,7 @@
           <a:lstStyle/>
           <a:p>
             <a:r>
-              <a:t>Introduce Enzo and set the evaluation lens.</a:t>
+              <a:t>Keep this short. Introduce the team and the game in plain words.</a:t>
             </a:r>
           </a:p>
         </p:txBody>
@@ -792,7 +792,7 @@
           <a:lstStyle/>
           <a:p>
             <a:r>
-              <a:t>Walk the five demands. One-trick robots were not enough.</a:t>
+              <a:t>Explain Crescendo like explaining a new sport.</a:t>
             </a:r>
           </a:p>
         </p:txBody>
@@ -862,7 +862,7 @@
           <a:lstStyle/>
           <a:p>
             <a:r>
-              <a:t>This rubric is the rest of the talk.</a:t>
+              <a:t>These five points are our checklist for the rest of the talk.</a:t>
             </a:r>
           </a:p>
         </p:txBody>
@@ -932,7 +932,7 @@
           <a:lstStyle/>
           <a:p>
             <a:r>
-              <a:t>Reference the public Enzo rebuild story without outcomes.</a:t>
+              <a:t>Praise the rebuild as smart teamwork, without talking about results.</a:t>
             </a:r>
           </a:p>
         </p:txBody>
@@ -1002,7 +1002,7 @@
           <a:lstStyle/>
           <a:p>
             <a:r>
-              <a:t>Keep claims qualitative. Possession quality first.</a:t>
+              <a:t>Use the basketball comparison if it helps the class.</a:t>
             </a:r>
           </a:p>
         </p:txBody>
@@ -1072,7 +1072,7 @@
           <a:lstStyle/>
           <a:p>
             <a:r>
-              <a:t>Dual-mode scoring = decision freedom.</a:t>
+              <a:t>Stress flexibility in simple terms.</a:t>
             </a:r>
           </a:p>
         </p:txBody>
@@ -1142,7 +1142,7 @@
           <a:lstStyle/>
           <a:p>
             <a:r>
-              <a:t>Balance teleop identity with real endgame.</a:t>
+              <a:t>Balance: score first, climb later — but both matter.</a:t>
             </a:r>
           </a:p>
         </p:txBody>
@@ -1212,7 +1212,7 @@
           <a:lstStyle/>
           <a:p>
             <a:r>
-              <a:t>Software is the multiplier.</a:t>
+              <a:t>Software = helpful tools for the human drivers.</a:t>
             </a:r>
           </a:p>
         </p:txBody>
@@ -4293,7 +4293,7 @@
               </a:spcAft>
             </a:pPr>
             <a:r>
-              <a:rPr sz="3400" b="1">
+              <a:rPr sz="3200" b="1">
                 <a:solidFill>
                   <a:srgbClr val="F2EBDF"/>
                 </a:solidFill>
@@ -4332,29 +4332,29 @@
               </a:spcAft>
             </a:pPr>
             <a:r>
-              <a:rPr sz="1800" b="0">
+              <a:rPr sz="2000" b="0">
                 <a:solidFill>
                   <a:srgbClr val="F2EBDF"/>
                 </a:solidFill>
                 <a:latin typeface="Arial"/>
               </a:rPr>
-              <a:t>Why Enzo is the best robot of FRC Crescendo</a:t>
-            </a:r>
-          </a:p>
-          <a:p>
-            <a:pPr>
-              <a:spcAft>
-                <a:spcPts val="800"/>
-              </a:spcAft>
-            </a:pPr>
-            <a:r>
-              <a:rPr sz="1800" b="0">
+              <a:t>Why Enzo is the best robot in Crescendo</a:t>
+            </a:r>
+          </a:p>
+          <a:p>
+            <a:pPr>
+              <a:spcAft>
+                <a:spcPts val="800"/>
+              </a:spcAft>
+            </a:pPr>
+            <a:r>
+              <a:rPr sz="2000" b="0">
                 <a:solidFill>
                   <a:srgbClr val="F2EBDF"/>
                 </a:solidFill>
                 <a:latin typeface="Arial"/>
               </a:rPr>
-              <a:t>A design-first argument  ·  5–7 minutes</a:t>
+              <a:t>A short talk about smart design  ·  about 5–7 minutes</a:t>
             </a:r>
           </a:p>
         </p:txBody>
@@ -4458,7 +4458,7 @@
                 </a:solidFill>
                 <a:latin typeface="Arial"/>
               </a:rPr>
-              <a:t>THE ARGUMENT</a:t>
+              <a:t>THE BIG IDEA</a:t>
             </a:r>
           </a:p>
         </p:txBody>
@@ -4491,7 +4491,7 @@
               </a:spcAft>
             </a:pPr>
             <a:r>
-              <a:rPr sz="3400" b="1">
+              <a:rPr sz="3200" b="1">
                 <a:solidFill>
                   <a:srgbClr val="F2EBDF"/>
                 </a:solidFill>
@@ -4530,109 +4530,77 @@
               </a:spcAft>
             </a:pPr>
             <a:r>
-              <a:rPr sz="1800" b="0">
+              <a:rPr sz="2000" b="0">
                 <a:solidFill>
                   <a:srgbClr val="F2EBDF"/>
                 </a:solidFill>
                 <a:latin typeface="Arial"/>
               </a:rPr>
-              <a:t>1. It answers Crescendo’s real problem: Notes, dual scoring, Stage</a:t>
-            </a:r>
-          </a:p>
-          <a:p>
-            <a:pPr>
-              <a:spcAft>
-                <a:spcPts val="800"/>
-              </a:spcAft>
-            </a:pPr>
-            <a:r>
-              <a:rPr sz="1800" b="0">
+              <a:t>1. Built for the whole Crescendo game, not just one trick</a:t>
+            </a:r>
+          </a:p>
+          <a:p>
+            <a:pPr>
+              <a:spcAft>
+                <a:spcPts val="800"/>
+              </a:spcAft>
+            </a:pPr>
+            <a:r>
+              <a:rPr sz="2000" b="0">
                 <a:solidFill>
                   <a:srgbClr val="F2EBDF"/>
                 </a:solidFill>
                 <a:latin typeface="Arial"/>
               </a:rPr>
-              <a:t>2. It was rebuilt with courage when the field demanded better</a:t>
-            </a:r>
-          </a:p>
-          <a:p>
-            <a:pPr>
-              <a:spcAft>
-                <a:spcPts val="800"/>
-              </a:spcAft>
-            </a:pPr>
-            <a:r>
-              <a:rPr sz="1800" b="0">
+              <a:t>2. The team rebuilt it when they needed to</a:t>
+            </a:r>
+          </a:p>
+          <a:p>
+            <a:pPr>
+              <a:spcAft>
+                <a:spcPts val="800"/>
+              </a:spcAft>
+            </a:pPr>
+            <a:r>
+              <a:rPr sz="2000" b="0">
                 <a:solidFill>
                   <a:srgbClr val="F2EBDF"/>
                 </a:solidFill>
                 <a:latin typeface="Arial"/>
               </a:rPr>
-              <a:t>3. It prioritizes possession quality</a:t>
-            </a:r>
-          </a:p>
-          <a:p>
-            <a:pPr>
-              <a:spcAft>
-                <a:spcPts val="800"/>
-              </a:spcAft>
-            </a:pPr>
-            <a:r>
-              <a:rPr sz="1800" b="0">
+              <a:t>3. Focuses on grabbing and controlling Notes</a:t>
+            </a:r>
+          </a:p>
+          <a:p>
+            <a:pPr>
+              <a:spcAft>
+                <a:spcPts val="800"/>
+              </a:spcAft>
+            </a:pPr>
+            <a:r>
+              <a:rPr sz="2000" b="0">
                 <a:solidFill>
                   <a:srgbClr val="F2EBDF"/>
                 </a:solidFill>
                 <a:latin typeface="Arial"/>
               </a:rPr>
-              <a:t>4. It stays versatile: Speaker pressure and Amp utility</a:t>
-            </a:r>
-          </a:p>
-          <a:p>
-            <a:pPr>
-              <a:spcAft>
-                <a:spcPts val="800"/>
-              </a:spcAft>
-            </a:pPr>
-            <a:r>
-              <a:rPr sz="1800" b="0">
+              <a:t>4. Can score in more than one way</a:t>
+            </a:r>
+          </a:p>
+          <a:p>
+            <a:pPr>
+              <a:spcAft>
+                <a:spcPts val="800"/>
+              </a:spcAft>
+            </a:pPr>
+            <a:r>
+              <a:rPr sz="2000" b="0">
                 <a:solidFill>
                   <a:srgbClr val="F2EBDF"/>
                 </a:solidFill>
                 <a:latin typeface="Arial"/>
               </a:rPr>
-              <a:t>5. It closes the loop with software drivers can trust</a:t>
-            </a:r>
-          </a:p>
-          <a:p>
-            <a:pPr>
-              <a:spcAft>
-                <a:spcPts val="800"/>
-              </a:spcAft>
-            </a:pPr>
-            <a:r>
-              <a:rPr sz="1800" b="0">
-                <a:solidFill>
-                  <a:srgbClr val="F2EBDF"/>
-                </a:solidFill>
-                <a:latin typeface="Arial"/>
-              </a:rPr>
-              <a:t/>
-            </a:r>
-          </a:p>
-          <a:p>
-            <a:pPr>
-              <a:spcAft>
-                <a:spcPts val="800"/>
-              </a:spcAft>
-            </a:pPr>
-            <a:r>
-              <a:rPr sz="1800" b="0">
-                <a:solidFill>
-                  <a:srgbClr val="F2EBDF"/>
-                </a:solidFill>
-                <a:latin typeface="Arial"/>
-              </a:rPr>
-              <a:t>Five reasons — all design, no scoreboard.</a:t>
+              <a:t>5. Software helps drivers do the hard parts</a:t>
             </a:r>
           </a:p>
         </p:txBody>
@@ -4736,7 +4704,7 @@
                 </a:solidFill>
                 <a:latin typeface="Arial"/>
               </a:rPr>
-              <a:t>CLOSE</a:t>
+              <a:t>WRAP-UP</a:t>
             </a:r>
           </a:p>
         </p:txBody>
@@ -4769,13 +4737,13 @@
               </a:spcAft>
             </a:pPr>
             <a:r>
-              <a:rPr sz="3400" b="1">
+              <a:rPr sz="3200" b="1">
                 <a:solidFill>
                   <a:srgbClr val="F2EBDF"/>
                 </a:solidFill>
                 <a:latin typeface="Arial"/>
               </a:rPr>
-              <a:t>Enzo is best because it was designed to be.</a:t>
+              <a:t>Enzo is best because of how it was built.</a:t>
             </a:r>
           </a:p>
         </p:txBody>
@@ -4808,44 +4776,28 @@
               </a:spcAft>
             </a:pPr>
             <a:r>
-              <a:rPr sz="1800" b="0">
+              <a:rPr sz="2000" b="0">
                 <a:solidFill>
                   <a:srgbClr val="F2EBDF"/>
                 </a:solidFill>
                 <a:latin typeface="Arial"/>
               </a:rPr>
-              <a:t>Not because of a bracket.</a:t>
-            </a:r>
-          </a:p>
-          <a:p>
-            <a:pPr>
-              <a:spcAft>
-                <a:spcPts val="800"/>
-              </a:spcAft>
-            </a:pPr>
-            <a:r>
-              <a:rPr sz="1800" b="0">
+              <a:t>Clear plan. Willing to improve. Easy to drive. Ready for the whole game.</a:t>
+            </a:r>
+          </a:p>
+          <a:p>
+            <a:pPr>
+              <a:spcAft>
+                <a:spcPts val="800"/>
+              </a:spcAft>
+            </a:pPr>
+            <a:r>
+              <a:rPr sz="2000" b="0">
                 <a:solidFill>
                   <a:srgbClr val="F2EBDF"/>
                 </a:solidFill>
                 <a:latin typeface="Arial"/>
               </a:rPr>
-              <a:t>Because Steampunk built clear strategy, fearless iteration, and a machine drivers — and alliances — can trust.</a:t>
-            </a:r>
-          </a:p>
-          <a:p>
-            <a:pPr>
-              <a:spcAft>
-                <a:spcPts val="800"/>
-              </a:spcAft>
-            </a:pPr>
-            <a:r>
-              <a:rPr sz="1800" b="0">
-                <a:solidFill>
-                  <a:srgbClr val="F2EBDF"/>
-                </a:solidFill>
-                <a:latin typeface="Arial"/>
-              </a:rPr>
               <a:t/>
             </a:r>
           </a:p>
@@ -4856,7 +4808,7 @@
               </a:spcAft>
             </a:pPr>
             <a:r>
-              <a:rPr sz="1800" b="0">
+              <a:rPr sz="2000" b="0">
                 <a:solidFill>
                   <a:srgbClr val="F2EBDF"/>
                 </a:solidFill>
@@ -4966,7 +4918,7 @@
                 </a:solidFill>
                 <a:latin typeface="Arial"/>
               </a:rPr>
-              <a:t>MEET THE ROBOT</a:t>
+              <a:t>WHO IS ENZO?</a:t>
             </a:r>
           </a:p>
         </p:txBody>
@@ -4999,13 +4951,13 @@
               </a:spcAft>
             </a:pPr>
             <a:r>
-              <a:rPr sz="3400" b="1">
+              <a:rPr sz="3200" b="1">
                 <a:solidFill>
                   <a:srgbClr val="F2EBDF"/>
                 </a:solidFill>
                 <a:latin typeface="Arial"/>
               </a:rPr>
-              <a:t>Enzo, built by Steampunk</a:t>
+              <a:t>Meet the robot</a:t>
             </a:r>
           </a:p>
         </p:txBody>
@@ -5038,23 +4990,23 @@
               </a:spcAft>
             </a:pPr>
             <a:r>
-              <a:rPr sz="1800" b="0">
+              <a:rPr sz="2000" b="0">
                 <a:solidFill>
                   <a:srgbClr val="F2EBDF"/>
                 </a:solidFill>
                 <a:latin typeface="Arial"/>
               </a:rPr>
-              <a:t>FRC Team 1577 — Aviv High School, Raanana.</a:t>
-            </a:r>
-          </a:p>
-          <a:p>
-            <a:pPr>
-              <a:spcAft>
-                <a:spcPts val="800"/>
-              </a:spcAft>
-            </a:pPr>
-            <a:r>
-              <a:rPr sz="1800" b="0">
+              <a:t>Enzo was built by FRC Team 1577, Steampunk, from Raanana, Israel.</a:t>
+            </a:r>
+          </a:p>
+          <a:p>
+            <a:pPr>
+              <a:spcAft>
+                <a:spcPts val="800"/>
+              </a:spcAft>
+            </a:pPr>
+            <a:r>
+              <a:rPr sz="2000" b="0">
                 <a:solidFill>
                   <a:srgbClr val="F2EBDF"/>
                 </a:solidFill>
@@ -5070,23 +5022,23 @@
               </a:spcAft>
             </a:pPr>
             <a:r>
-              <a:rPr sz="1800" b="0">
+              <a:rPr sz="2000" b="0">
                 <a:solidFill>
                   <a:srgbClr val="F2EBDF"/>
                 </a:solidFill>
                 <a:latin typeface="Arial"/>
               </a:rPr>
-              <a:t>Crescendo asks robots to collect Notes, score Speaker and Amp, and finish on Stage.</a:t>
-            </a:r>
-          </a:p>
-          <a:p>
-            <a:pPr>
-              <a:spcAft>
-                <a:spcPts val="800"/>
-              </a:spcAft>
-            </a:pPr>
-            <a:r>
-              <a:rPr sz="1800" b="0">
+              <a:t>Crescendo is like a sports match for robots: pick up foam rings called Notes, score them, and climb at the end.</a:t>
+            </a:r>
+          </a:p>
+          <a:p>
+            <a:pPr>
+              <a:spcAft>
+                <a:spcPts val="800"/>
+              </a:spcAft>
+            </a:pPr>
+            <a:r>
+              <a:rPr sz="2000" b="0">
                 <a:solidFill>
                   <a:srgbClr val="F2EBDF"/>
                 </a:solidFill>
@@ -5102,13 +5054,13 @@
               </a:spcAft>
             </a:pPr>
             <a:r>
-              <a:rPr sz="1800" b="0">
+              <a:rPr sz="2000" b="0">
                 <a:solidFill>
                   <a:srgbClr val="F2EBDF"/>
                 </a:solidFill>
                 <a:latin typeface="Arial"/>
               </a:rPr>
-              <a:t>Today we judge Enzo by design quality — never by match tallies.</a:t>
+              <a:t>We’ll talk about how Enzo was designed — not about game scores.</a:t>
             </a:r>
           </a:p>
         </p:txBody>
@@ -5212,7 +5164,7 @@
                 </a:solidFill>
                 <a:latin typeface="Arial"/>
               </a:rPr>
-              <a:t>THE PROBLEM SPACE</a:t>
+              <a:t>THE CHALLENGE</a:t>
             </a:r>
           </a:p>
         </p:txBody>
@@ -5245,13 +5197,13 @@
               </a:spcAft>
             </a:pPr>
             <a:r>
-              <a:rPr sz="3400" b="1">
+              <a:rPr sz="3200" b="1">
                 <a:solidFill>
                   <a:srgbClr val="F2EBDF"/>
                 </a:solidFill>
                 <a:latin typeface="Arial"/>
               </a:rPr>
-              <a:t>What Crescendo demanded</a:t>
+              <a:t>What robots had to do</a:t>
             </a:r>
           </a:p>
         </p:txBody>
@@ -5284,77 +5236,77 @@
               </a:spcAft>
             </a:pPr>
             <a:r>
-              <a:rPr sz="1800" b="0">
+              <a:rPr sz="2000" b="0">
                 <a:solidFill>
                   <a:srgbClr val="F2EBDF"/>
                 </a:solidFill>
                 <a:latin typeface="Arial"/>
               </a:rPr>
-              <a:t>• Forgiving Note acquisition under contact</a:t>
-            </a:r>
-          </a:p>
-          <a:p>
-            <a:pPr>
-              <a:spcAft>
-                <a:spcPts val="800"/>
-              </a:spcAft>
-            </a:pPr>
-            <a:r>
-              <a:rPr sz="1800" b="0">
+              <a:t>• Pick up Notes from the floor quickly</a:t>
+            </a:r>
+          </a:p>
+          <a:p>
+            <a:pPr>
+              <a:spcAft>
+                <a:spcPts val="800"/>
+              </a:spcAft>
+            </a:pPr>
+            <a:r>
+              <a:rPr sz="2000" b="0">
                 <a:solidFill>
                   <a:srgbClr val="F2EBDF"/>
                 </a:solidFill>
                 <a:latin typeface="Arial"/>
               </a:rPr>
-              <a:t>• Fast Speaker cycles plus Amp utility for the alliance</a:t>
-            </a:r>
-          </a:p>
-          <a:p>
-            <a:pPr>
-              <a:spcAft>
-                <a:spcPts val="800"/>
-              </a:spcAft>
-            </a:pPr>
-            <a:r>
-              <a:rPr sz="1800" b="0">
+              <a:t>• Shoot them into a big goal (the Speaker)</a:t>
+            </a:r>
+          </a:p>
+          <a:p>
+            <a:pPr>
+              <a:spcAft>
+                <a:spcPts val="800"/>
+              </a:spcAft>
+            </a:pPr>
+            <a:r>
+              <a:rPr sz="2000" b="0">
                 <a:solidFill>
                   <a:srgbClr val="F2EBDF"/>
                 </a:solidFill>
                 <a:latin typeface="Arial"/>
               </a:rPr>
-              <a:t>• Stage presence without wrecking teleop scoring</a:t>
-            </a:r>
-          </a:p>
-          <a:p>
-            <a:pPr>
-              <a:spcAft>
-                <a:spcPts val="800"/>
-              </a:spcAft>
-            </a:pPr>
-            <a:r>
-              <a:rPr sz="1800" b="0">
+              <a:t>• Also put Notes in a side goal (the Amp)</a:t>
+            </a:r>
+          </a:p>
+          <a:p>
+            <a:pPr>
+              <a:spcAft>
+                <a:spcPts val="800"/>
+              </a:spcAft>
+            </a:pPr>
+            <a:r>
+              <a:rPr sz="2000" b="0">
                 <a:solidFill>
                   <a:srgbClr val="F2EBDF"/>
                 </a:solidFill>
                 <a:latin typeface="Arial"/>
               </a:rPr>
-              <a:t>• Mobility that survives defense</a:t>
-            </a:r>
-          </a:p>
-          <a:p>
-            <a:pPr>
-              <a:spcAft>
-                <a:spcPts val="800"/>
-              </a:spcAft>
-            </a:pPr>
-            <a:r>
-              <a:rPr sz="1800" b="0">
+              <a:t>• Climb onto a chain at the end of the match</a:t>
+            </a:r>
+          </a:p>
+          <a:p>
+            <a:pPr>
+              <a:spcAft>
+                <a:spcPts val="800"/>
+              </a:spcAft>
+            </a:pPr>
+            <a:r>
+              <a:rPr sz="2000" b="0">
                 <a:solidFill>
                   <a:srgbClr val="F2EBDF"/>
                 </a:solidFill>
                 <a:latin typeface="Arial"/>
               </a:rPr>
-              <a:t>• Software drivers can trust</a:t>
+              <a:t>• Keep moving even when other robots get in the way</a:t>
             </a:r>
           </a:p>
         </p:txBody>
@@ -5458,7 +5410,7 @@
                 </a:solidFill>
                 <a:latin typeface="Arial"/>
               </a:rPr>
-              <a:t>DEFINITION</a:t>
+              <a:t>WHAT “BEST” MEANS</a:t>
             </a:r>
           </a:p>
         </p:txBody>
@@ -5491,13 +5443,13 @@
               </a:spcAft>
             </a:pPr>
             <a:r>
-              <a:rPr sz="3400" b="1">
+              <a:rPr sz="3200" b="1">
                 <a:solidFill>
                   <a:srgbClr val="F2EBDF"/>
                 </a:solidFill>
                 <a:latin typeface="Arial"/>
               </a:rPr>
-              <a:t>How we define “best”</a:t>
+              <a:t>Not flashiest — smartest</a:t>
             </a:r>
           </a:p>
         </p:txBody>
@@ -5530,77 +5482,77 @@
               </a:spcAft>
             </a:pPr>
             <a:r>
-              <a:rPr sz="1800" b="0">
+              <a:rPr sz="2000" b="0">
                 <a:solidFill>
                   <a:srgbClr val="F2EBDF"/>
                 </a:solidFill>
                 <a:latin typeface="Arial"/>
               </a:rPr>
-              <a:t>Strategy clarity — every subsystem serves one game plan</a:t>
-            </a:r>
-          </a:p>
-          <a:p>
-            <a:pPr>
-              <a:spcAft>
-                <a:spcPts val="800"/>
-              </a:spcAft>
-            </a:pPr>
-            <a:r>
-              <a:rPr sz="1800" b="0">
+              <a:t>• Has a clear plan for the whole game</a:t>
+            </a:r>
+          </a:p>
+          <a:p>
+            <a:pPr>
+              <a:spcAft>
+                <a:spcPts val="800"/>
+              </a:spcAft>
+            </a:pPr>
+            <a:r>
+              <a:rPr sz="2000" b="0">
                 <a:solidFill>
                   <a:srgbClr val="F2EBDF"/>
                 </a:solidFill>
                 <a:latin typeface="Arial"/>
               </a:rPr>
-              <a:t>Cycle quality — intake → control → score is short and stable</a:t>
-            </a:r>
-          </a:p>
-          <a:p>
-            <a:pPr>
-              <a:spcAft>
-                <a:spcPts val="800"/>
-              </a:spcAft>
-            </a:pPr>
-            <a:r>
-              <a:rPr sz="1800" b="0">
+              <a:t>• Picks up and scores Notes smoothly</a:t>
+            </a:r>
+          </a:p>
+          <a:p>
+            <a:pPr>
+              <a:spcAft>
+                <a:spcPts val="800"/>
+              </a:spcAft>
+            </a:pPr>
+            <a:r>
+              <a:rPr sz="2000" b="0">
                 <a:solidFill>
                   <a:srgbClr val="F2EBDF"/>
                 </a:solidFill>
                 <a:latin typeface="Arial"/>
               </a:rPr>
-              <a:t>Role flexibility — scorer, cleaner, or endgame partner</a:t>
-            </a:r>
-          </a:p>
-          <a:p>
-            <a:pPr>
-              <a:spcAft>
-                <a:spcPts val="800"/>
-              </a:spcAft>
-            </a:pPr>
-            <a:r>
-              <a:rPr sz="1800" b="0">
+              <a:t>• Can help the team in more than one way</a:t>
+            </a:r>
+          </a:p>
+          <a:p>
+            <a:pPr>
+              <a:spcAft>
+                <a:spcPts val="800"/>
+              </a:spcAft>
+            </a:pPr>
+            <a:r>
+              <a:rPr sz="2000" b="0">
                 <a:solidFill>
                   <a:srgbClr val="F2EBDF"/>
                 </a:solidFill>
                 <a:latin typeface="Arial"/>
               </a:rPr>
-              <a:t>Iteration courage — redesign when the field teaches better</a:t>
-            </a:r>
-          </a:p>
-          <a:p>
-            <a:pPr>
-              <a:spcAft>
-                <a:spcPts val="800"/>
-              </a:spcAft>
-            </a:pPr>
-            <a:r>
-              <a:rPr sz="1800" b="0">
+              <a:t>• Gets better when the team finds problems</a:t>
+            </a:r>
+          </a:p>
+          <a:p>
+            <a:pPr>
+              <a:spcAft>
+                <a:spcPts val="800"/>
+              </a:spcAft>
+            </a:pPr>
+            <a:r>
+              <a:rPr sz="2000" b="0">
                 <a:solidFill>
                   <a:srgbClr val="F2EBDF"/>
                 </a:solidFill>
                 <a:latin typeface="Arial"/>
               </a:rPr>
-              <a:t>Driver trust — hard things feel ordinary at the controls</a:t>
+              <a:t>• Is easy for the drivers to control</a:t>
             </a:r>
           </a:p>
         </p:txBody>
@@ -5704,7 +5656,7 @@
                 </a:solidFill>
                 <a:latin typeface="Arial"/>
               </a:rPr>
-              <a:t>DESIGN CULTURE</a:t>
+              <a:t>IMPROVING THE ROBOT</a:t>
             </a:r>
           </a:p>
         </p:txBody>
@@ -5737,13 +5689,13 @@
               </a:spcAft>
             </a:pPr>
             <a:r>
-              <a:rPr sz="3400" b="1">
+              <a:rPr sz="3200" b="1">
                 <a:solidFill>
                   <a:srgbClr val="F2EBDF"/>
                 </a:solidFill>
                 <a:latin typeface="Arial"/>
               </a:rPr>
-              <a:t>Enzo was rebuilt when it had to be</a:t>
+              <a:t>They weren’t afraid to change it</a:t>
             </a:r>
           </a:p>
         </p:txBody>
@@ -5776,23 +5728,23 @@
               </a:spcAft>
             </a:pPr>
             <a:r>
-              <a:rPr sz="1800" b="0">
+              <a:rPr sz="2000" b="0">
                 <a:solidFill>
                   <a:srgbClr val="F2EBDF"/>
                 </a:solidFill>
                 <a:latin typeface="Arial"/>
               </a:rPr>
-              <a:t>After early district play, Steampunk chose a substantial redesign.</a:t>
-            </a:r>
-          </a:p>
-          <a:p>
-            <a:pPr>
-              <a:spcAft>
-                <a:spcPts val="800"/>
-              </a:spcAft>
-            </a:pPr>
-            <a:r>
-              <a:rPr sz="1800" b="0">
+              <a:t>Midway through the season, the team rebuilt big parts of Enzo.</a:t>
+            </a:r>
+          </a:p>
+          <a:p>
+            <a:pPr>
+              <a:spcAft>
+                <a:spcPts val="800"/>
+              </a:spcAft>
+            </a:pPr>
+            <a:r>
+              <a:rPr sz="2000" b="0">
                 <a:solidFill>
                   <a:srgbClr val="F2EBDF"/>
                 </a:solidFill>
@@ -5808,61 +5760,45 @@
               </a:spcAft>
             </a:pPr>
             <a:r>
-              <a:rPr sz="1800" b="0">
+              <a:rPr sz="2000" b="0">
                 <a:solidFill>
                   <a:srgbClr val="F2EBDF"/>
                 </a:solidFill>
                 <a:latin typeface="Arial"/>
               </a:rPr>
-              <a:t>Best robots are not frozen at first CAD.</a:t>
-            </a:r>
-          </a:p>
-          <a:p>
-            <a:pPr>
-              <a:spcAft>
-                <a:spcPts val="800"/>
-              </a:spcAft>
-            </a:pPr>
-            <a:r>
-              <a:rPr sz="1800" b="0">
+              <a:t>That means they listened to what wasn’t working and fixed it.</a:t>
+            </a:r>
+          </a:p>
+          <a:p>
+            <a:pPr>
+              <a:spcAft>
+                <a:spcPts val="800"/>
+              </a:spcAft>
+            </a:pPr>
+            <a:r>
+              <a:rPr sz="2000" b="0">
                 <a:solidFill>
                   <a:srgbClr val="F2EBDF"/>
                 </a:solidFill>
                 <a:latin typeface="Arial"/>
               </a:rPr>
-              <a:t>They update when reality disagrees with the design.</a:t>
-            </a:r>
-          </a:p>
-          <a:p>
-            <a:pPr>
-              <a:spcAft>
-                <a:spcPts val="800"/>
-              </a:spcAft>
-            </a:pPr>
-            <a:r>
-              <a:rPr sz="1800" b="0">
+              <a:t/>
+            </a:r>
+          </a:p>
+          <a:p>
+            <a:pPr>
+              <a:spcAft>
+                <a:spcPts val="800"/>
+              </a:spcAft>
+            </a:pPr>
+            <a:r>
+              <a:rPr sz="2000" b="0">
                 <a:solidFill>
                   <a:srgbClr val="F2EBDF"/>
                 </a:solidFill>
                 <a:latin typeface="Arial"/>
               </a:rPr>
-              <a:t/>
-            </a:r>
-          </a:p>
-          <a:p>
-            <a:pPr>
-              <a:spcAft>
-                <a:spcPts val="800"/>
-              </a:spcAft>
-            </a:pPr>
-            <a:r>
-              <a:rPr sz="1800" b="0">
-                <a:solidFill>
-                  <a:srgbClr val="F2EBDF"/>
-                </a:solidFill>
-                <a:latin typeface="Arial"/>
-              </a:rPr>
-              <a:t>That discipline is rarer than clever mechanisms — and more decisive.</a:t>
+              <a:t>Great engineering looks like that — not giving up on the first idea.</a:t>
             </a:r>
           </a:p>
         </p:txBody>
@@ -5966,7 +5902,7 @@
                 </a:solidFill>
                 <a:latin typeface="Arial"/>
               </a:rPr>
-              <a:t>SUBSYSTEM THESIS</a:t>
+              <a:t>PICKING UP GAME PIECES</a:t>
             </a:r>
           </a:p>
         </p:txBody>
@@ -5999,13 +5935,13 @@
               </a:spcAft>
             </a:pPr>
             <a:r>
-              <a:rPr sz="3400" b="1">
+              <a:rPr sz="3200" b="1">
                 <a:solidFill>
                   <a:srgbClr val="F2EBDF"/>
                 </a:solidFill>
                 <a:latin typeface="Arial"/>
               </a:rPr>
-              <a:t>Notes first: possession is power</a:t>
+              <a:t>If you can’t grab Notes, you can’t score</a:t>
             </a:r>
           </a:p>
         </p:txBody>
@@ -6038,23 +5974,23 @@
               </a:spcAft>
             </a:pPr>
             <a:r>
-              <a:rPr sz="1800" b="0">
+              <a:rPr sz="2000" b="0">
                 <a:solidFill>
                   <a:srgbClr val="F2EBDF"/>
                 </a:solidFill>
                 <a:latin typeface="Arial"/>
               </a:rPr>
-              <a:t>In Crescendo, the robot that owns Notes controls tempo.</a:t>
-            </a:r>
-          </a:p>
-          <a:p>
-            <a:pPr>
-              <a:spcAft>
-                <a:spcPts val="800"/>
-              </a:spcAft>
-            </a:pPr>
-            <a:r>
-              <a:rPr sz="1800" b="0">
+              <a:t>Enzo is built around getting Notes fast and keeping them under control.</a:t>
+            </a:r>
+          </a:p>
+          <a:p>
+            <a:pPr>
+              <a:spcAft>
+                <a:spcPts val="800"/>
+              </a:spcAft>
+            </a:pPr>
+            <a:r>
+              <a:rPr sz="2000" b="0">
                 <a:solidFill>
                   <a:srgbClr val="F2EBDF"/>
                 </a:solidFill>
@@ -6070,23 +6006,23 @@
               </a:spcAft>
             </a:pPr>
             <a:r>
-              <a:rPr sz="1800" b="0">
+              <a:rPr sz="2000" b="0">
                 <a:solidFill>
                   <a:srgbClr val="F2EBDF"/>
                 </a:solidFill>
                 <a:latin typeface="Arial"/>
               </a:rPr>
-              <a:t>A best-in-class bot treats intake as reliability: wide capture, quick centering, clean handoff.</a:t>
-            </a:r>
-          </a:p>
-          <a:p>
-            <a:pPr>
-              <a:spcAft>
-                <a:spcPts val="800"/>
-              </a:spcAft>
-            </a:pPr>
-            <a:r>
-              <a:rPr sz="1800" b="0">
+              <a:t>In this game, owning the Notes is like owning the basketball.</a:t>
+            </a:r>
+          </a:p>
+          <a:p>
+            <a:pPr>
+              <a:spcAft>
+                <a:spcPts val="800"/>
+              </a:spcAft>
+            </a:pPr>
+            <a:r>
+              <a:rPr sz="2000" b="0">
                 <a:solidFill>
                   <a:srgbClr val="F2EBDF"/>
                 </a:solidFill>
@@ -6102,13 +6038,13 @@
               </a:spcAft>
             </a:pPr>
             <a:r>
-              <a:rPr sz="1800" b="0">
+              <a:rPr sz="2000" b="0">
                 <a:solidFill>
                   <a:srgbClr val="F2EBDF"/>
                 </a:solidFill>
                 <a:latin typeface="Arial"/>
               </a:rPr>
-              <a:t>Enzo’s architecture is organized around uninterrupted Note flow — every possession becomes an alliance asset.</a:t>
+              <a:t>Enzo was made to take that job seriously.</a:t>
             </a:r>
           </a:p>
         </p:txBody>
@@ -6212,7 +6148,7 @@
                 </a:solidFill>
                 <a:latin typeface="Arial"/>
               </a:rPr>
-              <a:t>SCORING ARCHITECTURE</a:t>
+              <a:t>SCORING</a:t>
             </a:r>
           </a:p>
         </p:txBody>
@@ -6245,13 +6181,13 @@
               </a:spcAft>
             </a:pPr>
             <a:r>
-              <a:rPr sz="3400" b="1">
+              <a:rPr sz="3200" b="1">
                 <a:solidFill>
                   <a:srgbClr val="F2EBDF"/>
                 </a:solidFill>
                 <a:latin typeface="Arial"/>
               </a:rPr>
-              <a:t>Speaker threat + Amp utility</a:t>
+              <a:t>Two ways to score, one robot</a:t>
             </a:r>
           </a:p>
         </p:txBody>
@@ -6284,61 +6220,61 @@
               </a:spcAft>
             </a:pPr>
             <a:r>
-              <a:rPr sz="1800" b="0">
+              <a:rPr sz="2000" b="0">
                 <a:solidFill>
                   <a:srgbClr val="F2EBDF"/>
                 </a:solidFill>
                 <a:latin typeface="Arial"/>
               </a:rPr>
-              <a:t>• Speaker capability creates continuous cycle pressure</a:t>
-            </a:r>
-          </a:p>
-          <a:p>
-            <a:pPr>
-              <a:spcAft>
-                <a:spcPts val="800"/>
-              </a:spcAft>
-            </a:pPr>
-            <a:r>
-              <a:rPr sz="1800" b="0">
+              <a:t>• It can shoot into the Speaker for regular scoring</a:t>
+            </a:r>
+          </a:p>
+          <a:p>
+            <a:pPr>
+              <a:spcAft>
+                <a:spcPts val="800"/>
+              </a:spcAft>
+            </a:pPr>
+            <a:r>
+              <a:rPr sz="2000" b="0">
                 <a:solidFill>
                   <a:srgbClr val="F2EBDF"/>
                 </a:solidFill>
                 <a:latin typeface="Arial"/>
               </a:rPr>
-              <a:t>• Amp capability turns alliance coordination into leverage</a:t>
-            </a:r>
-          </a:p>
-          <a:p>
-            <a:pPr>
-              <a:spcAft>
-                <a:spcPts val="800"/>
-              </a:spcAft>
-            </a:pPr>
-            <a:r>
-              <a:rPr sz="1800" b="0">
+              <a:t>• It can also score in the Amp to help its alliance</a:t>
+            </a:r>
+          </a:p>
+          <a:p>
+            <a:pPr>
+              <a:spcAft>
+                <a:spcPts val="800"/>
+              </a:spcAft>
+            </a:pPr>
+            <a:r>
+              <a:rPr sz="2000" b="0">
                 <a:solidFill>
                   <a:srgbClr val="F2EBDF"/>
                 </a:solidFill>
                 <a:latin typeface="Arial"/>
               </a:rPr>
-              <a:t>• A unified package lets drivers choose under congestion</a:t>
-            </a:r>
-          </a:p>
-          <a:p>
-            <a:pPr>
-              <a:spcAft>
-                <a:spcPts val="800"/>
-              </a:spcAft>
-            </a:pPr>
-            <a:r>
-              <a:rPr sz="1800" b="0">
+              <a:t>• Drivers can pick the better option when the field is crowded</a:t>
+            </a:r>
+          </a:p>
+          <a:p>
+            <a:pPr>
+              <a:spcAft>
+                <a:spcPts val="800"/>
+              </a:spcAft>
+            </a:pPr>
+            <a:r>
+              <a:rPr sz="2000" b="0">
                 <a:solidFill>
                   <a:srgbClr val="F2EBDF"/>
                 </a:solidFill>
                 <a:latin typeface="Arial"/>
               </a:rPr>
-              <a:t>• Enzo’s claim is versatility in chaos — not one highlight shot</a:t>
+              <a:t>• Being flexible is better than only being good at one thing</a:t>
             </a:r>
           </a:p>
         </p:txBody>
@@ -6442,7 +6378,7 @@
                 </a:solidFill>
                 <a:latin typeface="Arial"/>
               </a:rPr>
-              <a:t>ENDGAME</a:t>
+              <a:t>THE END OF THE MATCH</a:t>
             </a:r>
           </a:p>
         </p:txBody>
@@ -6475,13 +6411,13 @@
               </a:spcAft>
             </a:pPr>
             <a:r>
-              <a:rPr sz="3400" b="1">
+              <a:rPr sz="3200" b="1">
                 <a:solidFill>
                   <a:srgbClr val="F2EBDF"/>
                 </a:solidFill>
                 <a:latin typeface="Arial"/>
               </a:rPr>
-              <a:t>Stage-ready without compromise</a:t>
+              <a:t>Climbing without breaking the plan</a:t>
             </a:r>
           </a:p>
         </p:txBody>
@@ -6514,23 +6450,23 @@
               </a:spcAft>
             </a:pPr>
             <a:r>
-              <a:rPr sz="1800" b="0">
+              <a:rPr sz="2000" b="0">
                 <a:solidFill>
                   <a:srgbClr val="F2EBDF"/>
                 </a:solidFill>
                 <a:latin typeface="Arial"/>
               </a:rPr>
-              <a:t>Climbing only matters if the robot can still score for most of the match.</a:t>
-            </a:r>
-          </a:p>
-          <a:p>
-            <a:pPr>
-              <a:spcAft>
-                <a:spcPts val="800"/>
-              </a:spcAft>
-            </a:pPr>
-            <a:r>
-              <a:rPr sz="1800" b="0">
+              <a:t>Some robots try so hard to climb that they get worse at scoring.</a:t>
+            </a:r>
+          </a:p>
+          <a:p>
+            <a:pPr>
+              <a:spcAft>
+                <a:spcPts val="800"/>
+              </a:spcAft>
+            </a:pPr>
+            <a:r>
+              <a:rPr sz="2000" b="0">
                 <a:solidFill>
                   <a:srgbClr val="F2EBDF"/>
                 </a:solidFill>
@@ -6546,45 +6482,13 @@
               </a:spcAft>
             </a:pPr>
             <a:r>
-              <a:rPr sz="1800" b="0">
+              <a:rPr sz="2000" b="0">
                 <a:solidFill>
                   <a:srgbClr val="F2EBDF"/>
                 </a:solidFill>
                 <a:latin typeface="Arial"/>
               </a:rPr>
-              <a:t>Designs that chase every endgame flourish often weaken teleop throughput.</a:t>
-            </a:r>
-          </a:p>
-          <a:p>
-            <a:pPr>
-              <a:spcAft>
-                <a:spcPts val="800"/>
-              </a:spcAft>
-            </a:pPr>
-            <a:r>
-              <a:rPr sz="1800" b="0">
-                <a:solidFill>
-                  <a:srgbClr val="F2EBDF"/>
-                </a:solidFill>
-                <a:latin typeface="Arial"/>
-              </a:rPr>
-              <a:t/>
-            </a:r>
-          </a:p>
-          <a:p>
-            <a:pPr>
-              <a:spcAft>
-                <a:spcPts val="800"/>
-              </a:spcAft>
-            </a:pPr>
-            <a:r>
-              <a:rPr sz="1800" b="0">
-                <a:solidFill>
-                  <a:srgbClr val="F2EBDF"/>
-                </a:solidFill>
-                <a:latin typeface="Arial"/>
-              </a:rPr>
-              <a:t>Enzo protects cycle identity first, then adds credible Stage presence alliances can trust.</a:t>
+              <a:t>Enzo stays strong at scoring during the match — and still can climb when it matters at the end.</a:t>
             </a:r>
           </a:p>
         </p:txBody>
@@ -6688,7 +6592,7 @@
                 </a:solidFill>
                 <a:latin typeface="Arial"/>
               </a:rPr>
-              <a:t>HUMAN–MACHINE LOOP</a:t>
+              <a:t>DRIVING THE ROBOT</a:t>
             </a:r>
           </a:p>
         </p:txBody>
@@ -6721,13 +6625,13 @@
               </a:spcAft>
             </a:pPr>
             <a:r>
-              <a:rPr sz="3400" b="1">
+              <a:rPr sz="3200" b="1">
                 <a:solidFill>
                   <a:srgbClr val="F2EBDF"/>
                 </a:solidFill>
                 <a:latin typeface="Arial"/>
               </a:rPr>
-              <a:t>Software makes Enzo feel inevitable</a:t>
+              <a:t>Good code makes hard jobs feel easy</a:t>
             </a:r>
           </a:p>
         </p:txBody>
@@ -6760,93 +6664,61 @@
               </a:spcAft>
             </a:pPr>
             <a:r>
-              <a:rPr sz="1800" b="0">
+              <a:rPr sz="2000" b="0">
                 <a:solidFill>
                   <a:srgbClr val="F2EBDF"/>
                 </a:solidFill>
                 <a:latin typeface="Arial"/>
               </a:rPr>
-              <a:t>Hardware sets the ceiling. Controls decide whether drivers reach it.</a:t>
-            </a:r>
-          </a:p>
-          <a:p>
-            <a:pPr>
-              <a:spcAft>
-                <a:spcPts val="800"/>
-              </a:spcAft>
-            </a:pPr>
-            <a:r>
-              <a:rPr sz="1800" b="0">
+              <a:t>• Helps the robot aim and score more consistently</a:t>
+            </a:r>
+          </a:p>
+          <a:p>
+            <a:pPr>
+              <a:spcAft>
+                <a:spcPts val="800"/>
+              </a:spcAft>
+            </a:pPr>
+            <a:r>
+              <a:rPr sz="2000" b="0">
                 <a:solidFill>
                   <a:srgbClr val="F2EBDF"/>
                 </a:solidFill>
                 <a:latin typeface="Arial"/>
               </a:rPr>
-              <a:t/>
-            </a:r>
-          </a:p>
-          <a:p>
-            <a:pPr>
-              <a:spcAft>
-                <a:spcPts val="800"/>
-              </a:spcAft>
-            </a:pPr>
-            <a:r>
-              <a:rPr sz="1800" b="0">
+              <a:t>• Gives drivers clear controls instead of button chaos</a:t>
+            </a:r>
+          </a:p>
+          <a:p>
+            <a:pPr>
+              <a:spcAft>
+                <a:spcPts val="800"/>
+              </a:spcAft>
+            </a:pPr>
+            <a:r>
+              <a:rPr sz="2000" b="0">
                 <a:solidFill>
                   <a:srgbClr val="F2EBDF"/>
                 </a:solidFill>
                 <a:latin typeface="Arial"/>
               </a:rPr>
-              <a:t>• State-aware scoring workflows cut button chaos</a:t>
-            </a:r>
-          </a:p>
-          <a:p>
-            <a:pPr>
-              <a:spcAft>
-                <a:spcPts val="800"/>
-              </a:spcAft>
-            </a:pPr>
-            <a:r>
-              <a:rPr sz="1800" b="0">
+              <a:t>• Uses cameras and sensors so the robot “sees” the field</a:t>
+            </a:r>
+          </a:p>
+          <a:p>
+            <a:pPr>
+              <a:spcAft>
+                <a:spcPts val="800"/>
+              </a:spcAft>
+            </a:pPr>
+            <a:r>
+              <a:rPr sz="2000" b="0">
                 <a:solidFill>
                   <a:srgbClr val="F2EBDF"/>
                 </a:solidFill>
                 <a:latin typeface="Arial"/>
               </a:rPr>
-              <a:t>• Vision turns “almost lined up” into “ready to release”</a:t>
-            </a:r>
-          </a:p>
-          <a:p>
-            <a:pPr>
-              <a:spcAft>
-                <a:spcPts val="800"/>
-              </a:spcAft>
-            </a:pPr>
-            <a:r>
-              <a:rPr sz="1800" b="0">
-                <a:solidFill>
-                  <a:srgbClr val="F2EBDF"/>
-                </a:solidFill>
-                <a:latin typeface="Arial"/>
-              </a:rPr>
-              <a:t>• Honest autonomous feedback makes teleop trustworthy</a:t>
-            </a:r>
-          </a:p>
-          <a:p>
-            <a:pPr>
-              <a:spcAft>
-                <a:spcPts val="800"/>
-              </a:spcAft>
-            </a:pPr>
-            <a:r>
-              <a:rPr sz="1800" b="0">
-                <a:solidFill>
-                  <a:srgbClr val="F2EBDF"/>
-                </a:solidFill>
-                <a:latin typeface="Arial"/>
-              </a:rPr>
-              <a:t>• When drivers trust the robot, strategy expands</a:t>
+              <a:t>• When drivers trust the robot, they can play smarter</a:t>
             </a:r>
           </a:p>
         </p:txBody>

</xml_diff>

<commit_message>
Use plain 9th-grade words throughout Enzo slides
Remove advanced wording (no “demos,” software jargon, etc.) and keep
everyday explanations for a high-school audience.

Co-authored-by: SivaBKPalla <SivaBKPalla@users.noreply.github.com>
</commit_message>
<xml_diff>
--- a/enzo-presentation/Enzo_Crescendo_GoogleSlides.pptx
+++ b/enzo-presentation/Enzo_Crescendo_GoogleSlides.pptx
@@ -512,7 +512,7 @@
           <a:lstStyle/>
           <a:p>
             <a:r>
-              <a:t>Say the robot name clearly. This talk is about design, not scores.</a:t>
+              <a:t>Say the robot name clearly. Talk about design, not scores.</a:t>
             </a:r>
           </a:p>
         </p:txBody>
@@ -582,7 +582,7 @@
           <a:lstStyle/>
           <a:p>
             <a:r>
-              <a:t>Slow down and hit each of the five points.</a:t>
+              <a:t>Slow down on each of the five points.</a:t>
             </a:r>
           </a:p>
         </p:txBody>
@@ -652,7 +652,7 @@
           <a:lstStyle/>
           <a:p>
             <a:r>
-              <a:t>End here. Invite simple questions about design or the game.</a:t>
+              <a:t>Stop here and take questions.</a:t>
             </a:r>
           </a:p>
         </p:txBody>
@@ -722,7 +722,7 @@
           <a:lstStyle/>
           <a:p>
             <a:r>
-              <a:t>Keep this short. Introduce the team and the game in plain words.</a:t>
+              <a:t>Keep this short and plain.</a:t>
             </a:r>
           </a:p>
         </p:txBody>
@@ -792,7 +792,7 @@
           <a:lstStyle/>
           <a:p>
             <a:r>
-              <a:t>Explain Crescendo like explaining a new sport.</a:t>
+              <a:t>Explain the game like a new sport.</a:t>
             </a:r>
           </a:p>
         </p:txBody>
@@ -862,7 +862,7 @@
           <a:lstStyle/>
           <a:p>
             <a:r>
-              <a:t>These five points are our checklist for the rest of the talk.</a:t>
+              <a:t>These five points guide the rest of the talk.</a:t>
             </a:r>
           </a:p>
         </p:txBody>
@@ -932,7 +932,7 @@
           <a:lstStyle/>
           <a:p>
             <a:r>
-              <a:t>Praise the rebuild as smart teamwork, without talking about results.</a:t>
+              <a:t>Praise fixing problems. No scores.</a:t>
             </a:r>
           </a:p>
         </p:txBody>
@@ -1002,7 +1002,7 @@
           <a:lstStyle/>
           <a:p>
             <a:r>
-              <a:t>Use the basketball comparison if it helps the class.</a:t>
+              <a:t>Basketball comparison helps.</a:t>
             </a:r>
           </a:p>
         </p:txBody>
@@ -1072,7 +1072,7 @@
           <a:lstStyle/>
           <a:p>
             <a:r>
-              <a:t>Stress flexibility in simple terms.</a:t>
+              <a:t>Keep it simple: two scoring options.</a:t>
             </a:r>
           </a:p>
         </p:txBody>
@@ -1142,7 +1142,7 @@
           <a:lstStyle/>
           <a:p>
             <a:r>
-              <a:t>Balance: score first, climb later — but both matter.</a:t>
+              <a:t>Score during the match, climb at the end.</a:t>
             </a:r>
           </a:p>
         </p:txBody>
@@ -1212,7 +1212,7 @@
           <a:lstStyle/>
           <a:p>
             <a:r>
-              <a:t>Software = helpful tools for the human drivers.</a:t>
+              <a:t>Code = the robot’s computer programs.</a:t>
             </a:r>
           </a:p>
         </p:txBody>
@@ -4260,7 +4260,7 @@
                 </a:solidFill>
                 <a:latin typeface="Arial"/>
               </a:rPr>
-              <a:t>TEAM 1577 STEAMPUNK  ·  FRC CRESCENDO</a:t>
+              <a:t>TEAM 1577 STEAMPUNK  ·  ROBOT GAME: CRESCENDO</a:t>
             </a:r>
           </a:p>
         </p:txBody>
@@ -4354,7 +4354,7 @@
                 </a:solidFill>
                 <a:latin typeface="Arial"/>
               </a:rPr>
-              <a:t>A short talk about smart design  ·  about 5–7 minutes</a:t>
+              <a:t>A short talk about how it was built  ·  about 5 to 7 minutes</a:t>
             </a:r>
           </a:p>
         </p:txBody>
@@ -4393,7 +4393,7 @@
                 </a:solidFill>
                 <a:latin typeface="Arial"/>
               </a:rPr>
-              <a:t>ENZO  ·  FRC Crescendo  ·  Team 1577 Steampunk  ·  1/11</a:t>
+              <a:t>ENZO  ·  Crescendo  ·  Team 1577 Steampunk  ·  1/11</a:t>
             </a:r>
           </a:p>
         </p:txBody>
@@ -4458,7 +4458,7 @@
                 </a:solidFill>
                 <a:latin typeface="Arial"/>
               </a:rPr>
-              <a:t>THE BIG IDEA</a:t>
+              <a:t>PUTTING IT TOGETHER</a:t>
             </a:r>
           </a:p>
         </p:txBody>
@@ -4536,7 +4536,7 @@
                 </a:solidFill>
                 <a:latin typeface="Arial"/>
               </a:rPr>
-              <a:t>1. Built for the whole Crescendo game, not just one trick</a:t>
+              <a:t>1. Built for the whole game, not just one trick</a:t>
             </a:r>
           </a:p>
           <a:p>
@@ -4552,7 +4552,7 @@
                 </a:solidFill>
                 <a:latin typeface="Arial"/>
               </a:rPr>
-              <a:t>2. The team rebuilt it when they needed to</a:t>
+              <a:t>2. The team changed it when it needed changes</a:t>
             </a:r>
           </a:p>
           <a:p>
@@ -4568,7 +4568,7 @@
                 </a:solidFill>
                 <a:latin typeface="Arial"/>
               </a:rPr>
-              <a:t>3. Focuses on grabbing and controlling Notes</a:t>
+              <a:t>3. Great at grabbing and holding Notes</a:t>
             </a:r>
           </a:p>
           <a:p>
@@ -4600,7 +4600,7 @@
                 </a:solidFill>
                 <a:latin typeface="Arial"/>
               </a:rPr>
-              <a:t>5. Software helps drivers do the hard parts</a:t>
+              <a:t>5. The code helps the drivers a lot</a:t>
             </a:r>
           </a:p>
         </p:txBody>
@@ -4639,7 +4639,7 @@
                 </a:solidFill>
                 <a:latin typeface="Arial"/>
               </a:rPr>
-              <a:t>ENZO  ·  FRC Crescendo  ·  Team 1577 Steampunk  ·  10/11</a:t>
+              <a:t>ENZO  ·  Crescendo  ·  Team 1577 Steampunk  ·  10/11</a:t>
             </a:r>
           </a:p>
         </p:txBody>
@@ -4704,7 +4704,7 @@
                 </a:solidFill>
                 <a:latin typeface="Arial"/>
               </a:rPr>
-              <a:t>WRAP-UP</a:t>
+              <a:t>THE END</a:t>
             </a:r>
           </a:p>
         </p:txBody>
@@ -4782,7 +4782,7 @@
                 </a:solidFill>
                 <a:latin typeface="Arial"/>
               </a:rPr>
-              <a:t>Clear plan. Willing to improve. Easy to drive. Ready for the whole game.</a:t>
+              <a:t>Simple plan. Willing to change. Easy to drive. Ready for the whole game.</a:t>
             </a:r>
           </a:p>
           <a:p>
@@ -4853,7 +4853,7 @@
                 </a:solidFill>
                 <a:latin typeface="Arial"/>
               </a:rPr>
-              <a:t>ENZO  ·  FRC Crescendo  ·  Team 1577 Steampunk  ·  11/11</a:t>
+              <a:t>ENZO  ·  Crescendo  ·  Team 1577 Steampunk  ·  11/11</a:t>
             </a:r>
           </a:p>
         </p:txBody>
@@ -4996,7 +4996,7 @@
                 </a:solidFill>
                 <a:latin typeface="Arial"/>
               </a:rPr>
-              <a:t>Enzo was built by FRC Team 1577, Steampunk, from Raanana, Israel.</a:t>
+              <a:t>High school students on Team 1577 (Steampunk) built Enzo in Raanana, Israel.</a:t>
             </a:r>
           </a:p>
           <a:p>
@@ -5028,7 +5028,7 @@
                 </a:solidFill>
                 <a:latin typeface="Arial"/>
               </a:rPr>
-              <a:t>Crescendo is like a sports match for robots: pick up foam rings called Notes, score them, and climb at the end.</a:t>
+              <a:t>Crescendo is a robot sports game. Robots pick up foam rings called Notes, score points, and climb at the end.</a:t>
             </a:r>
           </a:p>
           <a:p>
@@ -5060,7 +5060,7 @@
                 </a:solidFill>
                 <a:latin typeface="Arial"/>
               </a:rPr>
-              <a:t>We’ll talk about how Enzo was designed — not about game scores.</a:t>
+              <a:t>We’ll talk about how Enzo was built — not about game scores.</a:t>
             </a:r>
           </a:p>
         </p:txBody>
@@ -5099,7 +5099,7 @@
                 </a:solidFill>
                 <a:latin typeface="Arial"/>
               </a:rPr>
-              <a:t>ENZO  ·  FRC Crescendo  ·  Team 1577 Steampunk  ·  2/11</a:t>
+              <a:t>ENZO  ·  Crescendo  ·  Team 1577 Steampunk  ·  2/11</a:t>
             </a:r>
           </a:p>
         </p:txBody>
@@ -5164,7 +5164,7 @@
                 </a:solidFill>
                 <a:latin typeface="Arial"/>
               </a:rPr>
-              <a:t>THE CHALLENGE</a:t>
+              <a:t>THE GAME</a:t>
             </a:r>
           </a:p>
         </p:txBody>
@@ -5242,7 +5242,7 @@
                 </a:solidFill>
                 <a:latin typeface="Arial"/>
               </a:rPr>
-              <a:t>• Pick up Notes from the floor quickly</a:t>
+              <a:t>• Pick up Notes from the floor fast</a:t>
             </a:r>
           </a:p>
           <a:p>
@@ -5258,7 +5258,7 @@
                 </a:solidFill>
                 <a:latin typeface="Arial"/>
               </a:rPr>
-              <a:t>• Shoot them into a big goal (the Speaker)</a:t>
+              <a:t>• Shoot Notes into a big goal called the Speaker</a:t>
             </a:r>
           </a:p>
           <a:p>
@@ -5274,7 +5274,7 @@
                 </a:solidFill>
                 <a:latin typeface="Arial"/>
               </a:rPr>
-              <a:t>• Also put Notes in a side goal (the Amp)</a:t>
+              <a:t>• Also put Notes in a side goal called the Amp</a:t>
             </a:r>
           </a:p>
           <a:p>
@@ -5290,7 +5290,7 @@
                 </a:solidFill>
                 <a:latin typeface="Arial"/>
               </a:rPr>
-              <a:t>• Climb onto a chain at the end of the match</a:t>
+              <a:t>• Climb a chain near the end of the match</a:t>
             </a:r>
           </a:p>
           <a:p>
@@ -5306,7 +5306,7 @@
                 </a:solidFill>
                 <a:latin typeface="Arial"/>
               </a:rPr>
-              <a:t>• Keep moving even when other robots get in the way</a:t>
+              <a:t>• Keep driving even when other robots block them</a:t>
             </a:r>
           </a:p>
         </p:txBody>
@@ -5345,7 +5345,7 @@
                 </a:solidFill>
                 <a:latin typeface="Arial"/>
               </a:rPr>
-              <a:t>ENZO  ·  FRC Crescendo  ·  Team 1577 Steampunk  ·  3/11</a:t>
+              <a:t>ENZO  ·  Crescendo  ·  Team 1577 Steampunk  ·  3/11</a:t>
             </a:r>
           </a:p>
         </p:txBody>
@@ -5449,7 +5449,7 @@
                 </a:solidFill>
                 <a:latin typeface="Arial"/>
               </a:rPr>
-              <a:t>Not flashiest — smartest</a:t>
+              <a:t>Not the flashiest — the smartest</a:t>
             </a:r>
           </a:p>
         </p:txBody>
@@ -5488,7 +5488,7 @@
                 </a:solidFill>
                 <a:latin typeface="Arial"/>
               </a:rPr>
-              <a:t>• Has a clear plan for the whole game</a:t>
+              <a:t>• Has a simple plan for the whole game</a:t>
             </a:r>
           </a:p>
           <a:p>
@@ -5504,7 +5504,7 @@
                 </a:solidFill>
                 <a:latin typeface="Arial"/>
               </a:rPr>
-              <a:t>• Picks up and scores Notes smoothly</a:t>
+              <a:t>• Picks up and scores Notes without drama</a:t>
             </a:r>
           </a:p>
           <a:p>
@@ -5520,7 +5520,7 @@
                 </a:solidFill>
                 <a:latin typeface="Arial"/>
               </a:rPr>
-              <a:t>• Can help the team in more than one way</a:t>
+              <a:t>• Can help its partners in more than one way</a:t>
             </a:r>
           </a:p>
           <a:p>
@@ -5536,7 +5536,7 @@
                 </a:solidFill>
                 <a:latin typeface="Arial"/>
               </a:rPr>
-              <a:t>• Gets better when the team finds problems</a:t>
+              <a:t>• Gets fixed when something is wrong</a:t>
             </a:r>
           </a:p>
           <a:p>
@@ -5552,7 +5552,7 @@
                 </a:solidFill>
                 <a:latin typeface="Arial"/>
               </a:rPr>
-              <a:t>• Is easy for the drivers to control</a:t>
+              <a:t>• Is easy for the drivers to use</a:t>
             </a:r>
           </a:p>
         </p:txBody>
@@ -5591,7 +5591,7 @@
                 </a:solidFill>
                 <a:latin typeface="Arial"/>
               </a:rPr>
-              <a:t>ENZO  ·  FRC Crescendo  ·  Team 1577 Steampunk  ·  4/11</a:t>
+              <a:t>ENZO  ·  Crescendo  ·  Team 1577 Steampunk  ·  4/11</a:t>
             </a:r>
           </a:p>
         </p:txBody>
@@ -5656,7 +5656,7 @@
                 </a:solidFill>
                 <a:latin typeface="Arial"/>
               </a:rPr>
-              <a:t>IMPROVING THE ROBOT</a:t>
+              <a:t>MAKING IT BETTER</a:t>
             </a:r>
           </a:p>
         </p:txBody>
@@ -5695,7 +5695,7 @@
                 </a:solidFill>
                 <a:latin typeface="Arial"/>
               </a:rPr>
-              <a:t>They weren’t afraid to change it</a:t>
+              <a:t>They changed Enzo when they had to</a:t>
             </a:r>
           </a:p>
         </p:txBody>
@@ -5734,7 +5734,7 @@
                 </a:solidFill>
                 <a:latin typeface="Arial"/>
               </a:rPr>
-              <a:t>Midway through the season, the team rebuilt big parts of Enzo.</a:t>
+              <a:t>In the middle of the season, the team took Enzo apart and built big parts again.</a:t>
             </a:r>
           </a:p>
           <a:p>
@@ -5766,39 +5766,7 @@
                 </a:solidFill>
                 <a:latin typeface="Arial"/>
               </a:rPr>
-              <a:t>That means they listened to what wasn’t working and fixed it.</a:t>
-            </a:r>
-          </a:p>
-          <a:p>
-            <a:pPr>
-              <a:spcAft>
-                <a:spcPts val="800"/>
-              </a:spcAft>
-            </a:pPr>
-            <a:r>
-              <a:rPr sz="2000" b="0">
-                <a:solidFill>
-                  <a:srgbClr val="F2EBDF"/>
-                </a:solidFill>
-                <a:latin typeface="Arial"/>
-              </a:rPr>
-              <a:t/>
-            </a:r>
-          </a:p>
-          <a:p>
-            <a:pPr>
-              <a:spcAft>
-                <a:spcPts val="800"/>
-              </a:spcAft>
-            </a:pPr>
-            <a:r>
-              <a:rPr sz="2000" b="0">
-                <a:solidFill>
-                  <a:srgbClr val="F2EBDF"/>
-                </a:solidFill>
-                <a:latin typeface="Arial"/>
-              </a:rPr>
-              <a:t>Great engineering looks like that — not giving up on the first idea.</a:t>
+              <a:t>That’s smart. Good teams don’t stick with a bad first idea. They fix the robot.</a:t>
             </a:r>
           </a:p>
         </p:txBody>
@@ -5837,7 +5805,7 @@
                 </a:solidFill>
                 <a:latin typeface="Arial"/>
               </a:rPr>
-              <a:t>ENZO  ·  FRC Crescendo  ·  Team 1577 Steampunk  ·  5/11</a:t>
+              <a:t>ENZO  ·  Crescendo  ·  Team 1577 Steampunk  ·  5/11</a:t>
             </a:r>
           </a:p>
         </p:txBody>
@@ -5902,7 +5870,7 @@
                 </a:solidFill>
                 <a:latin typeface="Arial"/>
               </a:rPr>
-              <a:t>PICKING UP GAME PIECES</a:t>
+              <a:t>PICKING UP NOTES</a:t>
             </a:r>
           </a:p>
         </p:txBody>
@@ -5941,7 +5909,7 @@
                 </a:solidFill>
                 <a:latin typeface="Arial"/>
               </a:rPr>
-              <a:t>If you can’t grab Notes, you can’t score</a:t>
+              <a:t>No Notes = no points</a:t>
             </a:r>
           </a:p>
         </p:txBody>
@@ -5980,7 +5948,7 @@
                 </a:solidFill>
                 <a:latin typeface="Arial"/>
               </a:rPr>
-              <a:t>Enzo is built around getting Notes fast and keeping them under control.</a:t>
+              <a:t>Enzo is built to grab Notes quickly and hold onto them.</a:t>
             </a:r>
           </a:p>
           <a:p>
@@ -6012,7 +5980,7 @@
                 </a:solidFill>
                 <a:latin typeface="Arial"/>
               </a:rPr>
-              <a:t>In this game, owning the Notes is like owning the basketball.</a:t>
+              <a:t>In this game, having the Notes is like having the basketball.</a:t>
             </a:r>
           </a:p>
           <a:p>
@@ -6044,7 +6012,7 @@
                 </a:solidFill>
                 <a:latin typeface="Arial"/>
               </a:rPr>
-              <a:t>Enzo was made to take that job seriously.</a:t>
+              <a:t>Enzo was made to win that fight.</a:t>
             </a:r>
           </a:p>
         </p:txBody>
@@ -6083,7 +6051,7 @@
                 </a:solidFill>
                 <a:latin typeface="Arial"/>
               </a:rPr>
-              <a:t>ENZO  ·  FRC Crescendo  ·  Team 1577 Steampunk  ·  6/11</a:t>
+              <a:t>ENZO  ·  Crescendo  ·  Team 1577 Steampunk  ·  6/11</a:t>
             </a:r>
           </a:p>
         </p:txBody>
@@ -6148,7 +6116,7 @@
                 </a:solidFill>
                 <a:latin typeface="Arial"/>
               </a:rPr>
-              <a:t>SCORING</a:t>
+              <a:t>SCORING POINTS</a:t>
             </a:r>
           </a:p>
         </p:txBody>
@@ -6187,7 +6155,7 @@
                 </a:solidFill>
                 <a:latin typeface="Arial"/>
               </a:rPr>
-              <a:t>Two ways to score, one robot</a:t>
+              <a:t>Two ways to score</a:t>
             </a:r>
           </a:p>
         </p:txBody>
@@ -6226,7 +6194,7 @@
                 </a:solidFill>
                 <a:latin typeface="Arial"/>
               </a:rPr>
-              <a:t>• It can shoot into the Speaker for regular scoring</a:t>
+              <a:t>• Shoot into the Speaker</a:t>
             </a:r>
           </a:p>
           <a:p>
@@ -6242,7 +6210,7 @@
                 </a:solidFill>
                 <a:latin typeface="Arial"/>
               </a:rPr>
-              <a:t>• It can also score in the Amp to help its alliance</a:t>
+              <a:t>• Score in the Amp to help its partners</a:t>
             </a:r>
           </a:p>
           <a:p>
@@ -6258,7 +6226,7 @@
                 </a:solidFill>
                 <a:latin typeface="Arial"/>
               </a:rPr>
-              <a:t>• Drivers can pick the better option when the field is crowded</a:t>
+              <a:t>• Drivers can choose the better option when it’s crowded</a:t>
             </a:r>
           </a:p>
           <a:p>
@@ -6274,7 +6242,7 @@
                 </a:solidFill>
                 <a:latin typeface="Arial"/>
               </a:rPr>
-              <a:t>• Being flexible is better than only being good at one thing</a:t>
+              <a:t>• Doing both jobs is better than only doing one</a:t>
             </a:r>
           </a:p>
         </p:txBody>
@@ -6313,7 +6281,7 @@
                 </a:solidFill>
                 <a:latin typeface="Arial"/>
               </a:rPr>
-              <a:t>ENZO  ·  FRC Crescendo  ·  Team 1577 Steampunk  ·  7/11</a:t>
+              <a:t>ENZO  ·  Crescendo  ·  Team 1577 Steampunk  ·  7/11</a:t>
             </a:r>
           </a:p>
         </p:txBody>
@@ -6378,7 +6346,7 @@
                 </a:solidFill>
                 <a:latin typeface="Arial"/>
               </a:rPr>
-              <a:t>THE END OF THE MATCH</a:t>
+              <a:t>END OF THE MATCH</a:t>
             </a:r>
           </a:p>
         </p:txBody>
@@ -6417,7 +6385,7 @@
                 </a:solidFill>
                 <a:latin typeface="Arial"/>
               </a:rPr>
-              <a:t>Climbing without breaking the plan</a:t>
+              <a:t>Climbing without messing up scoring</a:t>
             </a:r>
           </a:p>
         </p:txBody>
@@ -6456,7 +6424,7 @@
                 </a:solidFill>
                 <a:latin typeface="Arial"/>
               </a:rPr>
-              <a:t>Some robots try so hard to climb that they get worse at scoring.</a:t>
+              <a:t>Some robots focus so much on climbing that they get worse at scoring.</a:t>
             </a:r>
           </a:p>
           <a:p>
@@ -6488,7 +6456,7 @@
                 </a:solidFill>
                 <a:latin typeface="Arial"/>
               </a:rPr>
-              <a:t>Enzo stays strong at scoring during the match — and still can climb when it matters at the end.</a:t>
+              <a:t>Enzo stays good at scoring during the match, and it can still climb at the end.</a:t>
             </a:r>
           </a:p>
         </p:txBody>
@@ -6527,7 +6495,7 @@
                 </a:solidFill>
                 <a:latin typeface="Arial"/>
               </a:rPr>
-              <a:t>ENZO  ·  FRC Crescendo  ·  Team 1577 Steampunk  ·  8/11</a:t>
+              <a:t>ENZO  ·  Crescendo  ·  Team 1577 Steampunk  ·  8/11</a:t>
             </a:r>
           </a:p>
         </p:txBody>
@@ -6592,7 +6560,7 @@
                 </a:solidFill>
                 <a:latin typeface="Arial"/>
               </a:rPr>
-              <a:t>DRIVING THE ROBOT</a:t>
+              <a:t>THE ROBOT’S COMPUTER CODE</a:t>
             </a:r>
           </a:p>
         </p:txBody>
@@ -6631,7 +6599,7 @@
                 </a:solidFill>
                 <a:latin typeface="Arial"/>
               </a:rPr>
-              <a:t>Good code makes hard jobs feel easy</a:t>
+              <a:t>Good code makes driving easier</a:t>
             </a:r>
           </a:p>
         </p:txBody>
@@ -6670,7 +6638,7 @@
                 </a:solidFill>
                 <a:latin typeface="Arial"/>
               </a:rPr>
-              <a:t>• Helps the robot aim and score more consistently</a:t>
+              <a:t>• Helps the robot aim better</a:t>
             </a:r>
           </a:p>
           <a:p>
@@ -6686,7 +6654,7 @@
                 </a:solidFill>
                 <a:latin typeface="Arial"/>
               </a:rPr>
-              <a:t>• Gives drivers clear controls instead of button chaos</a:t>
+              <a:t>• Gives drivers simple controls</a:t>
             </a:r>
           </a:p>
           <a:p>
@@ -6702,7 +6670,7 @@
                 </a:solidFill>
                 <a:latin typeface="Arial"/>
               </a:rPr>
-              <a:t>• Uses cameras and sensors so the robot “sees” the field</a:t>
+              <a:t>• Uses cameras so the robot can “see” the field</a:t>
             </a:r>
           </a:p>
           <a:p>
@@ -6718,7 +6686,7 @@
                 </a:solidFill>
                 <a:latin typeface="Arial"/>
               </a:rPr>
-              <a:t>• When drivers trust the robot, they can play smarter</a:t>
+              <a:t>• When drivers trust the robot, they play better</a:t>
             </a:r>
           </a:p>
         </p:txBody>
@@ -6757,7 +6725,7 @@
                 </a:solidFill>
                 <a:latin typeface="Arial"/>
               </a:rPr>
-              <a:t>ENZO  ·  FRC Crescendo  ·  Team 1577 Steampunk  ·  9/11</a:t>
+              <a:t>ENZO  ·  Crescendo  ·  Team 1577 Steampunk  ·  9/11</a:t>
             </a:r>
           </a:p>
         </p:txBody>

</xml_diff>